<commit_message>
Enhance DICOM handling and metadata detection. Update .gitignore to exclude additional output directories and files. Adjusted metrics in output files for better accuracy.
</commit_message>
<xml_diff>
--- a/rsna claims/CARPL Architecture & Deployment Deep-Dive.pptx
+++ b/rsna claims/CARPL Architecture & Deployment Deep-Dive.pptx
@@ -4615,6 +4615,50 @@
               <a:t>Vetted contours imported
 into robotic biopsy system</a:t>
             </a:r>
+          </a:p>
+        </p:txBody>
+      </p:sp>
+      <p:sp>
+        <p:nvSpPr>
+          <p:cNvPr id="26" name="Down Arrow 25"/>
+          <p:cNvSpPr/>
+          <p:nvPr/>
+        </p:nvSpPr>
+        <p:spPr>
+          <a:xfrm>
+            <a:off x="11350000" y="2720000"/>
+            <a:ext cx="150000" cy="350000"/>
+          </a:xfrm>
+          <a:prstGeom prst="downArrow">
+            <a:avLst/>
+          </a:prstGeom>
+          <a:solidFill>
+            <a:srgbClr val="006666"/>
+          </a:solidFill>
+          <a:ln>
+            <a:noFill/>
+          </a:ln>
+        </p:spPr>
+        <p:style>
+          <a:lnRef idx="1">
+            <a:schemeClr val="accent1"/>
+          </a:lnRef>
+          <a:fillRef idx="3">
+            <a:schemeClr val="accent1"/>
+          </a:fillRef>
+          <a:effectRef idx="2">
+            <a:schemeClr val="accent1"/>
+          </a:effectRef>
+          <a:fontRef idx="minor">
+            <a:schemeClr val="lt1"/>
+          </a:fontRef>
+        </p:style>
+        <p:txBody>
+          <a:bodyPr rtlCol="0" anchor="ctr"/>
+          <a:lstStyle/>
+          <a:p>
+            <a:pPr algn="ctr"/>
+            <a:endParaRPr/>
           </a:p>
         </p:txBody>
       </p:sp>

</xml_diff>